<commit_message>
chore: PPT 내 github 링크 첨부
</commit_message>
<xml_diff>
--- a/[SeSac] 노신영 발표자료.pptx
+++ b/[SeSac] 노신영 발표자료.pptx
@@ -123,6 +123,7 @@
 <p1510:revInfo xmlns:a="http://schemas.openxmlformats.org/drawingml/2006/main" xmlns:r="http://schemas.openxmlformats.org/officeDocument/2006/relationships" xmlns:p1510="http://schemas.microsoft.com/office/powerpoint/2015/10/main">
   <p1510:revLst>
     <p1510:client id="{25443721-E07D-4005-9033-4035AE811913}" v="11" dt="2026-10-01T05:23:19.768"/>
+    <p1510:client id="{48F7D977-53C1-48C7-8DF3-712C674FE971}" v="5" dt="2026-10-01T07:42:30.299"/>
   </p1510:revLst>
 </p1510:revInfo>
 </file>
@@ -132,7 +133,7 @@
   <pc:docChgLst>
     <pc:chgData name="신영 노" userId="8aa812b93d7ee537" providerId="LiveId" clId="{E249B1BF-21F2-428C-B4A9-6633A6C67FCE}"/>
     <pc:docChg chg="modSld">
-      <pc:chgData name="신영 노" userId="8aa812b93d7ee537" providerId="LiveId" clId="{E249B1BF-21F2-428C-B4A9-6633A6C67FCE}" dt="2026-10-01T05:23:19.768" v="46"/>
+      <pc:chgData name="신영 노" userId="8aa812b93d7ee537" providerId="LiveId" clId="{E249B1BF-21F2-428C-B4A9-6633A6C67FCE}" dt="2026-10-01T07:42:30.299" v="56" actId="20577"/>
       <pc:docMkLst>
         <pc:docMk/>
       </pc:docMkLst>
@@ -213,6 +214,21 @@
             <ac:grpSpMk id="23" creationId="{31102C3C-0A04-6ABB-35F5-CF2DE446F56D}"/>
           </ac:grpSpMkLst>
         </pc:grpChg>
+      </pc:sldChg>
+      <pc:sldChg chg="addSp modSp mod">
+        <pc:chgData name="신영 노" userId="8aa812b93d7ee537" providerId="LiveId" clId="{E249B1BF-21F2-428C-B4A9-6633A6C67FCE}" dt="2026-10-01T07:42:30.299" v="56" actId="20577"/>
+        <pc:sldMkLst>
+          <pc:docMk/>
+          <pc:sldMk cId="826509759" sldId="268"/>
+        </pc:sldMkLst>
+        <pc:spChg chg="add mod">
+          <ac:chgData name="신영 노" userId="8aa812b93d7ee537" providerId="LiveId" clId="{E249B1BF-21F2-428C-B4A9-6633A6C67FCE}" dt="2026-10-01T07:42:30.299" v="56" actId="20577"/>
+          <ac:spMkLst>
+            <pc:docMk/>
+            <pc:sldMk cId="826509759" sldId="268"/>
+            <ac:spMk id="3" creationId="{D25A6CBB-08CE-6B2E-EA26-623455D884D5}"/>
+          </ac:spMkLst>
+        </pc:spChg>
       </pc:sldChg>
     </pc:docChg>
   </pc:docChgLst>
@@ -11612,6 +11628,67 @@
           </a:p>
         </p:txBody>
       </p:sp>
+      <p:sp>
+        <p:nvSpPr>
+          <p:cNvPr id="3" name="TextBox 2">
+            <a:extLst>
+              <a:ext uri="{FF2B5EF4-FFF2-40B4-BE49-F238E27FC236}">
+                <a16:creationId xmlns:a16="http://schemas.microsoft.com/office/drawing/2014/main" id="{D25A6CBB-08CE-6B2E-EA26-623455D884D5}"/>
+              </a:ext>
+            </a:extLst>
+          </p:cNvPr>
+          <p:cNvSpPr txBox="1"/>
+          <p:nvPr/>
+        </p:nvSpPr>
+        <p:spPr>
+          <a:xfrm>
+            <a:off x="986010" y="4670322"/>
+            <a:ext cx="3415679" cy="461665"/>
+          </a:xfrm>
+          <a:prstGeom prst="rect">
+            <a:avLst/>
+          </a:prstGeom>
+          <a:noFill/>
+        </p:spPr>
+        <p:txBody>
+          <a:bodyPr wrap="none" rtlCol="0">
+            <a:spAutoFit/>
+          </a:bodyPr>
+          <a:lstStyle/>
+          <a:p>
+            <a:r>
+              <a:rPr lang="en-US" altLang="ko-KR" sz="1200" dirty="0">
+                <a:latin typeface="KoPubWorld돋움체 Light" panose="00000300000000000000" pitchFamily="2" charset="-127"/>
+                <a:ea typeface="KoPubWorld돋움체 Light" panose="00000300000000000000" pitchFamily="2" charset="-127"/>
+                <a:cs typeface="KoPubWorld돋움체 Light" panose="00000300000000000000" pitchFamily="2" charset="-127"/>
+                <a:hlinkClick r:id="rId2"/>
+              </a:rPr>
+              <a:t>https://github.com/sinn0o</a:t>
+            </a:r>
+            <a:r>
+              <a:rPr lang="en-US" altLang="ko-KR" sz="1200">
+                <a:latin typeface="KoPubWorld돋움체 Light" panose="00000300000000000000" pitchFamily="2" charset="-127"/>
+                <a:ea typeface="KoPubWorld돋움체 Light" panose="00000300000000000000" pitchFamily="2" charset="-127"/>
+                <a:cs typeface="KoPubWorld돋움체 Light" panose="00000300000000000000" pitchFamily="2" charset="-127"/>
+                <a:hlinkClick r:id="rId2"/>
+              </a:rPr>
+              <a:t>/java-word-counter</a:t>
+            </a:r>
+            <a:endParaRPr lang="en-US" altLang="ko-KR" sz="1200" dirty="0">
+              <a:latin typeface="KoPubWorld돋움체 Light" panose="00000300000000000000" pitchFamily="2" charset="-127"/>
+              <a:ea typeface="KoPubWorld돋움체 Light" panose="00000300000000000000" pitchFamily="2" charset="-127"/>
+              <a:cs typeface="KoPubWorld돋움체 Light" panose="00000300000000000000" pitchFamily="2" charset="-127"/>
+            </a:endParaRPr>
+          </a:p>
+          <a:p>
+            <a:endParaRPr lang="en-US" altLang="ko-KR" sz="1200">
+              <a:latin typeface="KoPubWorld돋움체 Light" panose="00000300000000000000" pitchFamily="2" charset="-127"/>
+              <a:ea typeface="KoPubWorld돋움체 Light" panose="00000300000000000000" pitchFamily="2" charset="-127"/>
+              <a:cs typeface="KoPubWorld돋움체 Light" panose="00000300000000000000" pitchFamily="2" charset="-127"/>
+            </a:endParaRPr>
+          </a:p>
+        </p:txBody>
+      </p:sp>
     </p:spTree>
     <p:extLst>
       <p:ext uri="{BB962C8B-B14F-4D97-AF65-F5344CB8AC3E}">

</xml_diff>